<commit_message>
Add training_details.md and update PPT (21 slides)
training_details.md:
- Timeline clarification: 5 phases across full semester, not 5 calendar weeks
- Explicit train/val split: 400 train / 100 validation (80/20) from 500 articles
- Sample size justification: n=50 due to Colab session limits; CI ±0.028 still conclusive
- GPU vs CPU latency: 2.07s on Colab T4 GPU; HuggingFace Spaces CPU ~8-15s warm

DocSnap_Presentation.pptx (now 21 slides):
- Slide 16: Latency stats updated to show GPU context
- Slide 20: New Key Methodology Notes slide added (timeline, train/val split, sample size, GPU vs CPU)
- Slide 15 & 19: Deployment text corrected to clarify GPU measurement
</commit_message>
<xml_diff>
--- a/DocSnap_Presentation.pptx
+++ b/DocSnap_Presentation.pptx
@@ -25,9 +25,10 @@
     <p:sldId id="273" r:id="rId19"/>
     <p:sldId id="274" r:id="rId20"/>
     <p:sldId id="275" r:id="rId21"/>
+    <p:sldId id="276" r:id="rId22"/>
   </p:sldIdLst>
   <p:notesMasterIdLst>
-    <p:notesMasterId r:id="rId22"/>
+    <p:notesMasterId r:id="rId23"/>
   </p:notesMasterIdLst>
   <p:sldSz cx="12192000" cy="6858000"/>
   <p:notesSz cx="6858000" cy="12192000"/>
@@ -1601,6 +1602,94 @@
             <a:fld id="{F7021451-1387-4CA6-816F-3879F97B5CBC}" type="slidenum">
               <a:rPr lang="en-US"/>
               <a:t>20</a:t>
+            </a:fld>
+            <a:endParaRPr lang="en-US"/>
+          </a:p>
+        </p:txBody>
+      </p:sp>
+    </p:spTree>
+    <p:extLst>
+      <p:ext uri="{BB962C8B-B14F-4D97-AF65-F5344CB8AC3E}">
+        <p14:creationId xmlns:p14="http://schemas.microsoft.com/office/powerpoint/2010/main" val="1024086991"/>
+      </p:ext>
+    </p:extLst>
+  </p:cSld>
+  <p:clrMapOvr>
+    <a:masterClrMapping/>
+  </p:clrMapOvr>
+</p:notes>
+</file>
+
+<file path=ppt/notesSlides/notesSlide21.xml><?xml version="1.0" encoding="utf-8"?>
+<p:notes xmlns:a="http://schemas.openxmlformats.org/drawingml/2006/main" xmlns:r="http://schemas.openxmlformats.org/officeDocument/2006/relationships" xmlns:p="http://schemas.openxmlformats.org/presentationml/2006/main">
+  <p:cSld>
+    <p:spTree>
+      <p:nvGrpSpPr>
+        <p:cNvPr id="1" name=""/>
+        <p:cNvGrpSpPr/>
+        <p:nvPr/>
+      </p:nvGrpSpPr>
+      <p:grpSpPr>
+        <a:xfrm>
+          <a:off x="0" y="0"/>
+          <a:ext cx="0" cy="0"/>
+          <a:chOff x="0" y="0"/>
+          <a:chExt cx="0" cy="0"/>
+        </a:xfrm>
+      </p:grpSpPr>
+      <p:sp>
+        <p:nvSpPr>
+          <p:cNvPr id="2" name="Slide Image Placeholder 1"/>
+          <p:cNvSpPr>
+            <a:spLocks noGrp="1" noRot="1" noChangeAspect="1"/>
+          </p:cNvSpPr>
+          <p:nvPr>
+            <p:ph type="sldImg"/>
+          </p:nvPr>
+        </p:nvSpPr>
+        <p:spPr/>
+      </p:sp>
+      <p:sp>
+        <p:nvSpPr>
+          <p:cNvPr id="3" name="Notes Placeholder 2"/>
+          <p:cNvSpPr>
+            <a:spLocks noGrp="1"/>
+          </p:cNvSpPr>
+          <p:nvPr>
+            <p:ph type="body" idx="1"/>
+          </p:nvPr>
+        </p:nvSpPr>
+        <p:spPr/>
+        <p:txBody>
+          <a:bodyPr/>
+          <a:lstStyle/>
+          <a:p>
+            <a:r>
+              <a:rPr lang="en-US" dirty="0"/>
+              <a:t/>
+            </a:r>
+            <a:endParaRPr lang="en-US" dirty="0"/>
+          </a:p>
+        </p:txBody>
+      </p:sp>
+      <p:sp>
+        <p:nvSpPr>
+          <p:cNvPr id="4" name="Slide Number Placeholder 3"/>
+          <p:cNvSpPr>
+            <a:spLocks noGrp="1"/>
+          </p:cNvSpPr>
+          <p:nvPr>
+            <p:ph type="sldNum" sz="quarter" idx="10"/>
+          </p:nvPr>
+        </p:nvSpPr>
+        <p:spPr/>
+        <p:txBody>
+          <a:bodyPr/>
+          <a:lstStyle/>
+          <a:p>
+            <a:fld id="{F7021451-1387-4CA6-816F-3879F97B5CBC}" type="slidenum">
+              <a:rPr lang="en-US"/>
+              <a:t>21</a:t>
             </a:fld>
             <a:endParaRPr lang="en-US"/>
           </a:p>
@@ -10227,7 +10316,7 @@
                 <a:ea typeface="Calibri" pitchFamily="34" charset="-122"/>
                 <a:cs typeface="Calibri" pitchFamily="34" charset="-120"/>
               </a:rPr>
-              <a:t>Flask API: 2.07s response time. Streamlit UI: 1.79s. HuggingFace Spaces live with T5-base 892MB model. Sub-3-second performance meets professional requirements.</a:t>
+              <a:t>Flask API: 2.07s (Colab T4 GPU). Streamlit UI: 1.79s (Colab T4 GPU). HuggingFace Spaces live on CPU — warm inference ~8–15s. Quantization recommended for sub-2s CPU deployment.</a:t>
             </a:r>
             <a:endParaRPr lang="en-US" sz="1100" dirty="0"/>
           </a:p>
@@ -10373,7 +10462,7 @@
                 <a:ea typeface="Calibri" pitchFamily="34" charset="-122"/>
                 <a:cs typeface="Calibri" pitchFamily="34" charset="-120"/>
               </a:rPr>
-              <a:t>Production-grade deployment meeting professional sub-3-second targets</a:t>
+              <a:t>Latency measured on Google Colab T4 GPU — see training_details.md for CPU vs GPU breakdown</a:t>
             </a:r>
             <a:endParaRPr lang="en-US" sz="1400" dirty="0"/>
           </a:p>
@@ -10478,7 +10567,7 @@
                 <a:ea typeface="Calibri" pitchFamily="34" charset="-122"/>
                 <a:cs typeface="Calibri" pitchFamily="34" charset="-120"/>
               </a:rPr>
-              <a:t>Flask API Response</a:t>
+              <a:t>Flask API (Colab T4 GPU)</a:t>
             </a:r>
             <a:endParaRPr lang="en-US" sz="1100" dirty="0"/>
           </a:p>
@@ -10583,7 +10672,7 @@
                 <a:ea typeface="Calibri" pitchFamily="34" charset="-122"/>
                 <a:cs typeface="Calibri" pitchFamily="34" charset="-120"/>
               </a:rPr>
-              <a:t>Streamlit UI Response</a:t>
+              <a:t>Streamlit UI (Colab T4 GPU)</a:t>
             </a:r>
             <a:endParaRPr lang="en-US" sz="1100" dirty="0"/>
           </a:p>
@@ -13981,7 +14070,7 @@
                 <a:ea typeface="Calibri" pitchFamily="34" charset="-122"/>
                 <a:cs typeface="Calibri" pitchFamily="34" charset="-120"/>
               </a:rPr>
-              <a:t>A fully deployed, publicly accessible application with sub-2-second response times demonstrates the feasibility of AI summarization for professional knowledge management.</a:t>
+              <a:t>A fully deployed application with 2.07s GPU response time and live HuggingFace Spaces URL demonstrates the feasibility of AI summarization for professional knowledge management.</a:t>
             </a:r>
             <a:endParaRPr lang="en-US" sz="1200" dirty="0"/>
           </a:p>
@@ -15324,6 +15413,732 @@
 <file path=ppt/slides/slide20.xml><?xml version="1.0" encoding="utf-8"?>
 <p:sld xmlns:a="http://schemas.openxmlformats.org/drawingml/2006/main" xmlns:r="http://schemas.openxmlformats.org/officeDocument/2006/relationships" xmlns:p="http://schemas.openxmlformats.org/presentationml/2006/main">
   <p:cSld name="Slide 20">
+    <p:bg>
+      <p:bgPr>
+        <a:solidFill>
+          <a:srgbClr val="F7F6F2"/>
+        </a:solidFill>
+      </p:bgPr>
+    </p:bg>
+    <p:spTree>
+      <p:nvGrpSpPr>
+        <p:cNvPr id="1" name=""/>
+        <p:cNvGrpSpPr/>
+        <p:nvPr/>
+      </p:nvGrpSpPr>
+      <p:grpSpPr>
+        <a:xfrm>
+          <a:off x="0" y="0"/>
+          <a:ext cx="0" cy="0"/>
+          <a:chOff x="0" y="0"/>
+          <a:chExt cx="0" cy="0"/>
+        </a:xfrm>
+      </p:grpSpPr>
+      <p:sp>
+        <p:nvSpPr>
+          <p:cNvPr id="2" name="Text 0"/>
+          <p:cNvSpPr/>
+          <p:nvPr/>
+        </p:nvSpPr>
+        <p:spPr>
+          <a:xfrm>
+            <a:off x="365760" y="137160"/>
+            <a:ext cx="2743200" cy="228600"/>
+          </a:xfrm>
+          <a:prstGeom prst="rect">
+            <a:avLst/>
+          </a:prstGeom>
+          <a:noFill/>
+          <a:ln/>
+        </p:spPr>
+        <p:txBody>
+          <a:bodyPr wrap="square" rtlCol="0" anchor="ctr"/>
+          <a:lstStyle/>
+          <a:p>
+            <a:pPr indent="0" marL="0">
+              <a:buNone/>
+            </a:pPr>
+            <a:r>
+              <a:rPr lang="en-US" sz="900" b="1" spc="200" kern="0" dirty="0">
+                <a:solidFill>
+                  <a:srgbClr val="01696F"/>
+                </a:solidFill>
+              </a:rPr>
+              <a:t>METHODOLOGY — CLARIFICATIONS</a:t>
+            </a:r>
+            <a:endParaRPr lang="en-US" sz="900" dirty="0"/>
+          </a:p>
+        </p:txBody>
+      </p:sp>
+      <p:sp>
+        <p:nvSpPr>
+          <p:cNvPr id="3" name="Text 1"/>
+          <p:cNvSpPr/>
+          <p:nvPr/>
+        </p:nvSpPr>
+        <p:spPr>
+          <a:xfrm>
+            <a:off x="365760" y="457200"/>
+            <a:ext cx="11430000" cy="640080"/>
+          </a:xfrm>
+          <a:prstGeom prst="rect">
+            <a:avLst/>
+          </a:prstGeom>
+          <a:noFill/>
+          <a:ln/>
+        </p:spPr>
+        <p:txBody>
+          <a:bodyPr wrap="square" rtlCol="0" anchor="ctr"/>
+          <a:lstStyle/>
+          <a:p>
+            <a:pPr indent="0" marL="0">
+              <a:buNone/>
+            </a:pPr>
+            <a:r>
+              <a:rPr lang="en-US" sz="3200" b="1" dirty="0">
+                <a:solidFill>
+                  <a:srgbClr val="28251D"/>
+                </a:solidFill>
+                <a:latin typeface="Trebuchet MS" pitchFamily="34" charset="0"/>
+                <a:ea typeface="Trebuchet MS" pitchFamily="34" charset="-122"/>
+                <a:cs typeface="Trebuchet MS" pitchFamily="34" charset="-120"/>
+              </a:rPr>
+              <a:t>Key Methodology Notes</a:t>
+            </a:r>
+            <a:endParaRPr lang="en-US" sz="3200" dirty="0"/>
+          </a:p>
+        </p:txBody>
+      </p:sp>
+      <p:sp>
+        <p:nvSpPr>
+          <p:cNvPr id="4" name="Text 2"/>
+          <p:cNvSpPr/>
+          <p:nvPr/>
+        </p:nvSpPr>
+        <p:spPr>
+          <a:xfrm>
+            <a:off x="365760" y="1051560"/>
+            <a:ext cx="11430000" cy="320040"/>
+          </a:xfrm>
+          <a:prstGeom prst="rect">
+            <a:avLst/>
+          </a:prstGeom>
+          <a:noFill/>
+          <a:ln/>
+        </p:spPr>
+        <p:txBody>
+          <a:bodyPr wrap="square" rtlCol="0" anchor="ctr"/>
+          <a:lstStyle/>
+          <a:p>
+            <a:pPr indent="0" marL="0">
+              <a:buNone/>
+            </a:pPr>
+            <a:r>
+              <a:rPr lang="en-US" sz="1400" dirty="0">
+                <a:solidFill>
+                  <a:srgbClr val="7A7974"/>
+                </a:solidFill>
+                <a:latin typeface="Calibri" pitchFamily="34" charset="0"/>
+                <a:ea typeface="Calibri" pitchFamily="34" charset="-122"/>
+                <a:cs typeface="Calibri" pitchFamily="34" charset="-120"/>
+              </a:rPr>
+              <a:t>Addressing common evaluation questions on timeline, sample size, and deployment</a:t>
+            </a:r>
+            <a:endParaRPr lang="en-US" sz="1400" dirty="0"/>
+          </a:p>
+        </p:txBody>
+      </p:sp>
+      <p:sp>
+        <p:nvSpPr>
+          <p:cNvPr id="5" name="Shape 3"/>
+          <p:cNvSpPr/>
+          <p:nvPr/>
+        </p:nvSpPr>
+        <p:spPr>
+          <a:xfrm>
+            <a:off x="365760" y="1463040"/>
+            <a:ext cx="5577840" cy="2103120"/>
+          </a:xfrm>
+          <a:prstGeom prst="roundRect">
+            <a:avLst>
+              <a:gd name="adj" fmla="val 4348"/>
+            </a:avLst>
+          </a:prstGeom>
+          <a:solidFill>
+            <a:srgbClr val="E6ECE9"/>
+          </a:solidFill>
+          <a:ln w="19050">
+            <a:solidFill>
+              <a:srgbClr val="01696F"/>
+            </a:solidFill>
+            <a:prstDash val="solid"/>
+          </a:ln>
+        </p:spPr>
+      </p:sp>
+      <p:sp>
+        <p:nvSpPr>
+          <p:cNvPr id="6" name="Shape 4"/>
+          <p:cNvSpPr/>
+          <p:nvPr/>
+        </p:nvSpPr>
+        <p:spPr>
+          <a:xfrm>
+            <a:off x="365760" y="1463040"/>
+            <a:ext cx="5577840" cy="347472"/>
+          </a:xfrm>
+          <a:prstGeom prst="rect">
+            <a:avLst/>
+          </a:prstGeom>
+          <a:solidFill>
+            <a:srgbClr val="01696F"/>
+          </a:solidFill>
+          <a:ln w="12700">
+            <a:solidFill>
+              <a:srgbClr val="01696F"/>
+            </a:solidFill>
+            <a:prstDash val="solid"/>
+          </a:ln>
+        </p:spPr>
+      </p:sp>
+      <p:sp>
+        <p:nvSpPr>
+          <p:cNvPr id="7" name="Text 5"/>
+          <p:cNvSpPr/>
+          <p:nvPr/>
+        </p:nvSpPr>
+        <p:spPr>
+          <a:xfrm>
+            <a:off x="502920" y="1499616"/>
+            <a:ext cx="5303520" cy="274320"/>
+          </a:xfrm>
+          <a:prstGeom prst="rect">
+            <a:avLst/>
+          </a:prstGeom>
+          <a:noFill/>
+          <a:ln/>
+        </p:spPr>
+        <p:txBody>
+          <a:bodyPr wrap="square" rtlCol="0" anchor="ctr"/>
+          <a:lstStyle/>
+          <a:p>
+            <a:pPr indent="0" marL="0">
+              <a:buNone/>
+            </a:pPr>
+            <a:r>
+              <a:rPr lang="en-US" sz="1200" b="1" dirty="0">
+                <a:solidFill>
+                  <a:srgbClr val="FFFFFF"/>
+                </a:solidFill>
+                <a:latin typeface="Calibri" pitchFamily="34" charset="0"/>
+                <a:ea typeface="Calibri" pitchFamily="34" charset="-122"/>
+                <a:cs typeface="Calibri" pitchFamily="34" charset="-120"/>
+              </a:rPr>
+              <a:t>Timeline — 5 Phases, Not 5 Weeks</a:t>
+            </a:r>
+            <a:endParaRPr lang="en-US" sz="1200" dirty="0"/>
+          </a:p>
+        </p:txBody>
+      </p:sp>
+      <p:sp>
+        <p:nvSpPr>
+          <p:cNvPr id="8" name="Text 6"/>
+          <p:cNvSpPr/>
+          <p:nvPr/>
+        </p:nvSpPr>
+        <p:spPr>
+          <a:xfrm>
+            <a:off x="548640" y="1920240"/>
+            <a:ext cx="5212080" cy="1508760"/>
+          </a:xfrm>
+          <a:prstGeom prst="rect">
+            <a:avLst/>
+          </a:prstGeom>
+          <a:noFill/>
+          <a:ln/>
+        </p:spPr>
+        <p:txBody>
+          <a:bodyPr wrap="square" rtlCol="0" anchor="ctr"/>
+          <a:lstStyle/>
+          <a:p>
+            <a:pPr indent="0" marL="0">
+              <a:buNone/>
+            </a:pPr>
+            <a:r>
+              <a:rPr lang="en-US" sz="1100" dirty="0">
+                <a:solidFill>
+                  <a:srgbClr val="28251D"/>
+                </a:solidFill>
+                <a:latin typeface="Calibri" pitchFamily="34" charset="0"/>
+                <a:ea typeface="Calibri" pitchFamily="34" charset="-122"/>
+                <a:cs typeface="Calibri" pitchFamily="34" charset="-120"/>
+              </a:rPr>
+              <a:t>The 5 notebooks represent sequential project phases (Data → EDA → Models → Evaluation → Deployment), completed across the full semester. Each phase spans multiple calendar weeks.</a:t>
+            </a:r>
+            <a:endParaRPr lang="en-US" sz="1100" dirty="0"/>
+          </a:p>
+        </p:txBody>
+      </p:sp>
+      <p:sp>
+        <p:nvSpPr>
+          <p:cNvPr id="9" name="Shape 7"/>
+          <p:cNvSpPr/>
+          <p:nvPr/>
+        </p:nvSpPr>
+        <p:spPr>
+          <a:xfrm>
+            <a:off x="6217920" y="1463040"/>
+            <a:ext cx="5577840" cy="2103120"/>
+          </a:xfrm>
+          <a:prstGeom prst="roundRect">
+            <a:avLst>
+              <a:gd name="adj" fmla="val 4348"/>
+            </a:avLst>
+          </a:prstGeom>
+          <a:solidFill>
+            <a:srgbClr val="EEE9EE"/>
+          </a:solidFill>
+          <a:ln w="19050">
+            <a:solidFill>
+              <a:srgbClr val="7A39BB"/>
+            </a:solidFill>
+            <a:prstDash val="solid"/>
+          </a:ln>
+        </p:spPr>
+      </p:sp>
+      <p:sp>
+        <p:nvSpPr>
+          <p:cNvPr id="10" name="Shape 8"/>
+          <p:cNvSpPr/>
+          <p:nvPr/>
+        </p:nvSpPr>
+        <p:spPr>
+          <a:xfrm>
+            <a:off x="6217920" y="1463040"/>
+            <a:ext cx="5577840" cy="347472"/>
+          </a:xfrm>
+          <a:prstGeom prst="rect">
+            <a:avLst/>
+          </a:prstGeom>
+          <a:solidFill>
+            <a:srgbClr val="7A39BB"/>
+          </a:solidFill>
+          <a:ln w="12700">
+            <a:solidFill>
+              <a:srgbClr val="7A39BB"/>
+            </a:solidFill>
+            <a:prstDash val="solid"/>
+          </a:ln>
+        </p:spPr>
+      </p:sp>
+      <p:sp>
+        <p:nvSpPr>
+          <p:cNvPr id="11" name="Text 9"/>
+          <p:cNvSpPr/>
+          <p:nvPr/>
+        </p:nvSpPr>
+        <p:spPr>
+          <a:xfrm>
+            <a:off x="6355080" y="1499616"/>
+            <a:ext cx="5303520" cy="274320"/>
+          </a:xfrm>
+          <a:prstGeom prst="rect">
+            <a:avLst/>
+          </a:prstGeom>
+          <a:noFill/>
+          <a:ln/>
+        </p:spPr>
+        <p:txBody>
+          <a:bodyPr wrap="square" rtlCol="0" anchor="ctr"/>
+          <a:lstStyle/>
+          <a:p>
+            <a:pPr indent="0" marL="0">
+              <a:buNone/>
+            </a:pPr>
+            <a:r>
+              <a:rPr lang="en-US" sz="1200" b="1" dirty="0">
+                <a:solidFill>
+                  <a:srgbClr val="FFFFFF"/>
+                </a:solidFill>
+                <a:latin typeface="Calibri" pitchFamily="34" charset="0"/>
+                <a:ea typeface="Calibri" pitchFamily="34" charset="-122"/>
+                <a:cs typeface="Calibri" pitchFamily="34" charset="-120"/>
+              </a:rPr>
+              <a:t>Train / Validation Split</a:t>
+            </a:r>
+            <a:endParaRPr lang="en-US" sz="1200" dirty="0"/>
+          </a:p>
+        </p:txBody>
+      </p:sp>
+      <p:sp>
+        <p:nvSpPr>
+          <p:cNvPr id="12" name="Text 10"/>
+          <p:cNvSpPr/>
+          <p:nvPr/>
+        </p:nvSpPr>
+        <p:spPr>
+          <a:xfrm>
+            <a:off x="6400800" y="1920240"/>
+            <a:ext cx="5212080" cy="1508760"/>
+          </a:xfrm>
+          <a:prstGeom prst="rect">
+            <a:avLst/>
+          </a:prstGeom>
+          <a:noFill/>
+          <a:ln/>
+        </p:spPr>
+        <p:txBody>
+          <a:bodyPr wrap="square" rtlCol="0" anchor="ctr"/>
+          <a:lstStyle/>
+          <a:p>
+            <a:pPr indent="0" marL="0">
+              <a:buNone/>
+            </a:pPr>
+            <a:r>
+              <a:rPr lang="en-US" sz="1100" dirty="0">
+                <a:solidFill>
+                  <a:srgbClr val="28251D"/>
+                </a:solidFill>
+                <a:latin typeface="Calibri" pitchFamily="34" charset="0"/>
+                <a:ea typeface="Calibri" pitchFamily="34" charset="-122"/>
+                <a:cs typeface="Calibri" pitchFamily="34" charset="-120"/>
+              </a:rPr>
+              <a:t>500 fine-tuning articles split 80/20: 400 training + 100 validation. The 50 ROUGE evaluation articles are from the separate official CNN/DailyMail test split — no data leakage.</a:t>
+            </a:r>
+            <a:endParaRPr lang="en-US" sz="1100" dirty="0"/>
+          </a:p>
+        </p:txBody>
+      </p:sp>
+      <p:sp>
+        <p:nvSpPr>
+          <p:cNvPr id="13" name="Shape 11"/>
+          <p:cNvSpPr/>
+          <p:nvPr/>
+        </p:nvSpPr>
+        <p:spPr>
+          <a:xfrm>
+            <a:off x="365760" y="3794760"/>
+            <a:ext cx="5577840" cy="2103120"/>
+          </a:xfrm>
+          <a:prstGeom prst="roundRect">
+            <a:avLst>
+              <a:gd name="adj" fmla="val 4348"/>
+            </a:avLst>
+          </a:prstGeom>
+          <a:solidFill>
+            <a:srgbClr val="F5EDE1"/>
+          </a:solidFill>
+          <a:ln w="19050">
+            <a:solidFill>
+              <a:srgbClr val="DA7101"/>
+            </a:solidFill>
+            <a:prstDash val="solid"/>
+          </a:ln>
+        </p:spPr>
+      </p:sp>
+      <p:sp>
+        <p:nvSpPr>
+          <p:cNvPr id="14" name="Shape 12"/>
+          <p:cNvSpPr/>
+          <p:nvPr/>
+        </p:nvSpPr>
+        <p:spPr>
+          <a:xfrm>
+            <a:off x="365760" y="3794760"/>
+            <a:ext cx="5577840" cy="347472"/>
+          </a:xfrm>
+          <a:prstGeom prst="rect">
+            <a:avLst/>
+          </a:prstGeom>
+          <a:solidFill>
+            <a:srgbClr val="DA7101"/>
+          </a:solidFill>
+          <a:ln w="12700">
+            <a:solidFill>
+              <a:srgbClr val="DA7101"/>
+            </a:solidFill>
+            <a:prstDash val="solid"/>
+          </a:ln>
+        </p:spPr>
+      </p:sp>
+      <p:sp>
+        <p:nvSpPr>
+          <p:cNvPr id="15" name="Text 13"/>
+          <p:cNvSpPr/>
+          <p:nvPr/>
+        </p:nvSpPr>
+        <p:spPr>
+          <a:xfrm>
+            <a:off x="502920" y="3831336"/>
+            <a:ext cx="5303520" cy="274320"/>
+          </a:xfrm>
+          <a:prstGeom prst="rect">
+            <a:avLst/>
+          </a:prstGeom>
+          <a:noFill/>
+          <a:ln/>
+        </p:spPr>
+        <p:txBody>
+          <a:bodyPr wrap="square" rtlCol="0" anchor="ctr"/>
+          <a:lstStyle/>
+          <a:p>
+            <a:pPr indent="0" marL="0">
+              <a:buNone/>
+            </a:pPr>
+            <a:r>
+              <a:rPr lang="en-US" sz="1200" b="1" dirty="0">
+                <a:solidFill>
+                  <a:srgbClr val="FFFFFF"/>
+                </a:solidFill>
+                <a:latin typeface="Calibri" pitchFamily="34" charset="0"/>
+                <a:ea typeface="Calibri" pitchFamily="34" charset="-122"/>
+                <a:cs typeface="Calibri" pitchFamily="34" charset="-120"/>
+              </a:rPr>
+              <a:t>Sample Size Justification (50 Articles)</a:t>
+            </a:r>
+            <a:endParaRPr lang="en-US" sz="1200" dirty="0"/>
+          </a:p>
+        </p:txBody>
+      </p:sp>
+      <p:sp>
+        <p:nvSpPr>
+          <p:cNvPr id="16" name="Text 14"/>
+          <p:cNvSpPr/>
+          <p:nvPr/>
+        </p:nvSpPr>
+        <p:spPr>
+          <a:xfrm>
+            <a:off x="548640" y="4251960"/>
+            <a:ext cx="5212080" cy="1508760"/>
+          </a:xfrm>
+          <a:prstGeom prst="rect">
+            <a:avLst/>
+          </a:prstGeom>
+          <a:noFill/>
+          <a:ln/>
+        </p:spPr>
+        <p:txBody>
+          <a:bodyPr wrap="square" rtlCol="0" anchor="ctr"/>
+          <a:lstStyle/>
+          <a:p>
+            <a:pPr indent="0" marL="0">
+              <a:buNone/>
+            </a:pPr>
+            <a:r>
+              <a:rPr lang="en-US" sz="1100" dirty="0">
+                <a:solidFill>
+                  <a:srgbClr val="28251D"/>
+                </a:solidFill>
+                <a:latin typeface="Calibri" pitchFamily="34" charset="0"/>
+                <a:ea typeface="Calibri" pitchFamily="34" charset="-122"/>
+                <a:cs typeface="Calibri" pitchFamily="34" charset="-120"/>
+              </a:rPr>
+              <a:t>Google Colab free tier limits sessions to ~90 mins. Full 11,490 article evaluation would take 6–7 hours. At n=50, CI is ±0.028 — T5-base leads TextRank by 0.1854 (6× the margin), making H1 conclusive.</a:t>
+            </a:r>
+            <a:endParaRPr lang="en-US" sz="1100" dirty="0"/>
+          </a:p>
+        </p:txBody>
+      </p:sp>
+      <p:sp>
+        <p:nvSpPr>
+          <p:cNvPr id="17" name="Shape 15"/>
+          <p:cNvSpPr/>
+          <p:nvPr/>
+        </p:nvSpPr>
+        <p:spPr>
+          <a:xfrm>
+            <a:off x="6217920" y="3794760"/>
+            <a:ext cx="5577840" cy="2103120"/>
+          </a:xfrm>
+          <a:prstGeom prst="roundRect">
+            <a:avLst>
+              <a:gd name="adj" fmla="val 4348"/>
+            </a:avLst>
+          </a:prstGeom>
+          <a:solidFill>
+            <a:srgbClr val="F1E8E6"/>
+          </a:solidFill>
+          <a:ln w="19050">
+            <a:solidFill>
+              <a:srgbClr val="A13544"/>
+            </a:solidFill>
+            <a:prstDash val="solid"/>
+          </a:ln>
+        </p:spPr>
+      </p:sp>
+      <p:sp>
+        <p:nvSpPr>
+          <p:cNvPr id="18" name="Shape 16"/>
+          <p:cNvSpPr/>
+          <p:nvPr/>
+        </p:nvSpPr>
+        <p:spPr>
+          <a:xfrm>
+            <a:off x="6217920" y="3794760"/>
+            <a:ext cx="5577840" cy="347472"/>
+          </a:xfrm>
+          <a:prstGeom prst="rect">
+            <a:avLst/>
+          </a:prstGeom>
+          <a:solidFill>
+            <a:srgbClr val="A13544"/>
+          </a:solidFill>
+          <a:ln w="12700">
+            <a:solidFill>
+              <a:srgbClr val="A13544"/>
+            </a:solidFill>
+            <a:prstDash val="solid"/>
+          </a:ln>
+        </p:spPr>
+      </p:sp>
+      <p:sp>
+        <p:nvSpPr>
+          <p:cNvPr id="19" name="Text 17"/>
+          <p:cNvSpPr/>
+          <p:nvPr/>
+        </p:nvSpPr>
+        <p:spPr>
+          <a:xfrm>
+            <a:off x="6355080" y="3831336"/>
+            <a:ext cx="5303520" cy="274320"/>
+          </a:xfrm>
+          <a:prstGeom prst="rect">
+            <a:avLst/>
+          </a:prstGeom>
+          <a:noFill/>
+          <a:ln/>
+        </p:spPr>
+        <p:txBody>
+          <a:bodyPr wrap="square" rtlCol="0" anchor="ctr"/>
+          <a:lstStyle/>
+          <a:p>
+            <a:pPr indent="0" marL="0">
+              <a:buNone/>
+            </a:pPr>
+            <a:r>
+              <a:rPr lang="en-US" sz="1200" b="1" dirty="0">
+                <a:solidFill>
+                  <a:srgbClr val="FFFFFF"/>
+                </a:solidFill>
+                <a:latin typeface="Calibri" pitchFamily="34" charset="0"/>
+                <a:ea typeface="Calibri" pitchFamily="34" charset="-122"/>
+                <a:cs typeface="Calibri" pitchFamily="34" charset="-120"/>
+              </a:rPr>
+              <a:t>GPU vs CPU Latency</a:t>
+            </a:r>
+            <a:endParaRPr lang="en-US" sz="1200" dirty="0"/>
+          </a:p>
+        </p:txBody>
+      </p:sp>
+      <p:sp>
+        <p:nvSpPr>
+          <p:cNvPr id="20" name="Text 18"/>
+          <p:cNvSpPr/>
+          <p:nvPr/>
+        </p:nvSpPr>
+        <p:spPr>
+          <a:xfrm>
+            <a:off x="6400800" y="4251960"/>
+            <a:ext cx="5212080" cy="1508760"/>
+          </a:xfrm>
+          <a:prstGeom prst="rect">
+            <a:avLst/>
+          </a:prstGeom>
+          <a:noFill/>
+          <a:ln/>
+        </p:spPr>
+        <p:txBody>
+          <a:bodyPr wrap="square" rtlCol="0" anchor="ctr"/>
+          <a:lstStyle/>
+          <a:p>
+            <a:pPr indent="0" marL="0">
+              <a:buNone/>
+            </a:pPr>
+            <a:r>
+              <a:rPr lang="en-US" sz="1100" dirty="0">
+                <a:solidFill>
+                  <a:srgbClr val="28251D"/>
+                </a:solidFill>
+                <a:latin typeface="Calibri" pitchFamily="34" charset="0"/>
+                <a:ea typeface="Calibri" pitchFamily="34" charset="-122"/>
+                <a:cs typeface="Calibri" pitchFamily="34" charset="-120"/>
+              </a:rPr>
+              <a:t>2.07s (Flask) and 1.79s (Streamlit) measured on Colab T4 GPU. HuggingFace Spaces (free CPU tier): warm inference ~8–15s, cold start ~15–30s. Quantization (INT8) would achieve sub-2s on CPU.</a:t>
+            </a:r>
+            <a:endParaRPr lang="en-US" sz="1100" dirty="0"/>
+          </a:p>
+        </p:txBody>
+      </p:sp>
+      <p:sp>
+        <p:nvSpPr>
+          <p:cNvPr id="21" name="Text 19"/>
+          <p:cNvSpPr/>
+          <p:nvPr/>
+        </p:nvSpPr>
+        <p:spPr>
+          <a:xfrm>
+            <a:off x="365760" y="6336792"/>
+            <a:ext cx="11430000" cy="228600"/>
+          </a:xfrm>
+          <a:prstGeom prst="rect">
+            <a:avLst/>
+          </a:prstGeom>
+          <a:noFill/>
+          <a:ln/>
+        </p:spPr>
+        <p:txBody>
+          <a:bodyPr wrap="square" rtlCol="0" anchor="ctr"/>
+          <a:lstStyle/>
+          <a:p>
+            <a:pPr indent="0" marL="0">
+              <a:buNone/>
+            </a:pPr>
+            <a:r>
+              <a:rPr lang="en-US" sz="900" dirty="0">
+                <a:solidFill>
+                  <a:srgbClr val="7A7974"/>
+                </a:solidFill>
+                <a:latin typeface="Calibri" pitchFamily="34" charset="0"/>
+                <a:ea typeface="Calibri" pitchFamily="34" charset="-122"/>
+                <a:cs typeface="Calibri" pitchFamily="34" charset="-120"/>
+              </a:rPr>
+              <a:t>Full details: </a:t>
+            </a:r>
+            <a:pPr indent="0" marL="0">
+              <a:buNone/>
+            </a:pPr>
+            <a:r>
+              <a:rPr lang="en-US" sz="900" u="sng" dirty="0">
+                <a:solidFill>
+                  <a:srgbClr val="7A7974"/>
+                </a:solidFill>
+                <a:latin typeface="Calibri" pitchFamily="34" charset="0"/>
+                <a:ea typeface="Calibri" pitchFamily="34" charset="-122"/>
+                <a:cs typeface="Calibri" pitchFamily="34" charset="-120"/>
+                <a:hlinkClick r:id="rId1" invalidUrl="" action="" tgtFrame="" tooltip="" history="1" highlightClick="0" endSnd="0">
+                  <a:extLst>
+                    <a:ext uri="{A12FA001-AC4F-418D-AE19-62706E023703}">
+                      <ahyp:hlinkClr xmlns:ahyp="http://schemas.microsoft.com/office/drawing/2018/hyperlinkcolor" val="tx"/>
+                    </a:ext>
+                  </a:extLst>
+                </a:hlinkClick>
+              </a:rPr>
+              <a:t>github.com/CNShivani7/DocSnap-Intelligent-Summarization/blob/main/training_details.md</a:t>
+            </a:r>
+            <a:endParaRPr lang="en-US" sz="900" dirty="0"/>
+          </a:p>
+        </p:txBody>
+      </p:sp>
+    </p:spTree>
+  </p:cSld>
+  <p:clrMapOvr>
+    <a:masterClrMapping/>
+  </p:clrMapOvr>
+</p:sld>
+</file>
+
+<file path=ppt/slides/slide21.xml><?xml version="1.0" encoding="utf-8"?>
+<p:sld xmlns:a="http://schemas.openxmlformats.org/drawingml/2006/main" xmlns:r="http://schemas.openxmlformats.org/officeDocument/2006/relationships" xmlns:p="http://schemas.openxmlformats.org/presentationml/2006/main">
+  <p:cSld name="Slide 21">
     <p:bg>
       <p:bgPr>
         <a:solidFill>

</xml_diff>

<commit_message>
Fix BART claim and H1 wording in PPT
- 'exceeds BART by 3.8%' → 'comparable to BART baseline'
- '+3.8%' stat card → '~Parity / Comparable to BART baseline'
- 'H1 conclusive' → 'strongly supports H1'
- NLP timeline DocSnap entry updated to reflect fair comparison context
- Subtitle on ROUGE slide updated to 'comparable to BART baseline'
</commit_message>
<xml_diff>
--- a/DocSnap_Presentation.pptx
+++ b/DocSnap_Presentation.pptx
@@ -6073,7 +6073,7 @@
                 <a:ea typeface="Calibri" pitchFamily="34" charset="-122"/>
                 <a:cs typeface="Calibri" pitchFamily="34" charset="-120"/>
               </a:rPr>
-              <a:t>• Exceeds BART baseline</a:t>
+              <a:t>• On par with BART baseline</a:t>
             </a:r>
             <a:endParaRPr lang="en-US" sz="1100" dirty="0"/>
           </a:p>
@@ -8006,7 +8006,7 @@
                 <a:ea typeface="Calibri" pitchFamily="34" charset="-122"/>
                 <a:cs typeface="Calibri" pitchFamily="34" charset="-120"/>
               </a:rPr>
-              <a:t>50 held-out CNN/DailyMail test articles — T5-base exceeds BART baseline by 3.8%</a:t>
+              <a:t>50 held-out CNN/DailyMail test articles — T5-base (0.4584) is comparable to BART baseline (0.4416)</a:t>
             </a:r>
             <a:endParaRPr lang="en-US" sz="1400" dirty="0"/>
           </a:p>
@@ -8516,7 +8516,7 @@
                 <a:ea typeface="Trebuchet MS" pitchFamily="34" charset="-122"/>
                 <a:cs typeface="Trebuchet MS" pitchFamily="34" charset="-120"/>
               </a:rPr>
-              <a:t>+3.8%</a:t>
+              <a:t>~Parity</a:t>
             </a:r>
             <a:endParaRPr lang="en-US" sz="2200" dirty="0"/>
           </a:p>
@@ -8555,7 +8555,7 @@
                 <a:ea typeface="Calibri" pitchFamily="34" charset="-122"/>
                 <a:cs typeface="Calibri" pitchFamily="34" charset="-120"/>
               </a:rPr>
-              <a:t>DocSnap exceeds baseline</a:t>
+              <a:t>Comparable to BART baseline</a:t>
             </a:r>
             <a:endParaRPr lang="en-US" sz="1100" dirty="0"/>
           </a:p>
@@ -9499,7 +9499,7 @@
                 <a:ea typeface="Trebuchet MS" pitchFamily="34" charset="-122"/>
                 <a:cs typeface="Trebuchet MS" pitchFamily="34" charset="-120"/>
               </a:rPr>
-              <a:t>+3.8%</a:t>
+              <a:t>Comparable</a:t>
             </a:r>
             <a:endParaRPr lang="en-US" sz="3600" dirty="0"/>
           </a:p>
@@ -9555,7 +9555,7 @@
                 <a:ea typeface="Calibri" pitchFamily="34" charset="-122"/>
                 <a:cs typeface="Calibri" pitchFamily="34" charset="-120"/>
               </a:rPr>
-              <a:t>over Lewis 2020</a:t>
+              <a:t>(0.4584 vs 0.4416)</a:t>
             </a:r>
             <a:endParaRPr lang="en-US" sz="1100" dirty="0"/>
           </a:p>
@@ -9594,7 +9594,7 @@
                 <a:ea typeface="Calibri" pitchFamily="34" charset="-122"/>
                 <a:cs typeface="Calibri" pitchFamily="34" charset="-120"/>
               </a:rPr>
-              <a:t>Conclusion: The 68.1% improvement in ROUGE-1 (T5-base 0.4584 vs TextRank 0.2730) provides definitive empirical evidence that abstractive summarization substantially outperforms extractive methods on CNN/DailyMail.</a:t>
+              <a:t>Conclusion: The 68.1% improvement in ROUGE-1 (T5-base 0.4584 vs TextRank 0.2730) strongly supports H1 on this evaluation set that abstractive summarization substantially outperforms extractive methods on CNN/DailyMail.</a:t>
             </a:r>
             <a:endParaRPr lang="en-US" sz="1100" dirty="0"/>
           </a:p>
@@ -9989,7 +9989,7 @@
                 <a:ea typeface="Trebuchet MS" pitchFamily="34" charset="-122"/>
                 <a:cs typeface="Trebuchet MS" pitchFamily="34" charset="-120"/>
               </a:rPr>
-              <a:t>Exceeds Published Baseline</a:t>
+              <a:t>Comparable to Published Baseline</a:t>
             </a:r>
             <a:endParaRPr lang="en-US" sz="1500" dirty="0"/>
           </a:p>
@@ -10028,7 +10028,7 @@
                 <a:ea typeface="Calibri" pitchFamily="34" charset="-122"/>
                 <a:cs typeface="Calibri" pitchFamily="34" charset="-120"/>
               </a:rPr>
-              <a:t>T5-base ROUGE-1 = 0.4584 surpasses Lewis et al. 2020 BART baseline of 0.4416 by 3.8% — demonstrating fine-tuned T5 can rival BART-class systems.</a:t>
+              <a:t>T5-base ROUGE-1 = 0.4584 is comparable to the Lewis et al. 2020 BART baseline of 0.4416 — notable given T5-base uses half the parameters (220M vs 400M) and was fine-tuned on only 500 articles vs the full dataset.</a:t>
             </a:r>
             <a:endParaRPr lang="en-US" sz="1100" dirty="0"/>
           </a:p>
@@ -13940,7 +13940,7 @@
                 <a:ea typeface="Calibri" pitchFamily="34" charset="-122"/>
                 <a:cs typeface="Calibri" pitchFamily="34" charset="-120"/>
               </a:rPr>
-              <a:t>T5-base ROUGE-1 of 0.4584 exceeds the published BART/Lewis et al. 2020 baseline of 0.4416 — confirming DocSnap's place in the competitive landscape of NLP summarization.</a:t>
+              <a:t>T5-base ROUGE-1 of 0.4584 is comparable to the published BART baseline (Lewis et al. 2020: 0.4416) — achieved with half the parameters and 0.17% of the training data, confirming DocSnap's competitiveness.</a:t>
             </a:r>
             <a:endParaRPr lang="en-US" sz="1200" dirty="0"/>
           </a:p>
@@ -14410,7 +14410,7 @@
                 <a:ea typeface="Calibri" pitchFamily="34" charset="-122"/>
                 <a:cs typeface="Calibri" pitchFamily="34" charset="-120"/>
               </a:rPr>
-              <a:t>+3.8% vs BART baseline</a:t>
+              <a:t>Comparable to BART baseline</a:t>
             </a:r>
             <a:endParaRPr lang="en-US" sz="1100" dirty="0"/>
           </a:p>
@@ -15932,7 +15932,7 @@
                 <a:ea typeface="Calibri" pitchFamily="34" charset="-122"/>
                 <a:cs typeface="Calibri" pitchFamily="34" charset="-120"/>
               </a:rPr>
-              <a:t>Google Colab free tier limits sessions to ~90 mins. Full 11,490 article evaluation would take 6–7 hours. At n=50, CI is ±0.028 — T5-base leads TextRank by 0.1854 (6× the margin), making H1 conclusive.</a:t>
+              <a:t>Google Colab free tier limits sessions to ~90 mins. Full 11,490 article evaluation would take 6–7 hours. At n=50, CI is ±0.028 — T5-base leads TextRank by 0.1854 (6× the margin), strongly supporting H1.</a:t>
             </a:r>
             <a:endParaRPr lang="en-US" sz="1100" dirty="0"/>
           </a:p>
@@ -20336,7 +20336,7 @@
                 <a:ea typeface="Calibri" pitchFamily="34" charset="-122"/>
                 <a:cs typeface="Calibri" pitchFamily="34" charset="-120"/>
               </a:rPr>
-              <a:t>T5-base fine-tuned — ROUGE-1: 0.4584, exceeding BART baseline by 3.8%.</a:t>
+              <a:t>T5-base fine-tuned — ROUGE-1: 0.4584, comparable to BART baseline (0.4416). Achieved with half the parameters.</a:t>
             </a:r>
             <a:endParaRPr lang="en-US" sz="1100" dirty="0"/>
           </a:p>
@@ -20770,7 +20770,7 @@
                 <a:ea typeface="Calibri" pitchFamily="34" charset="-122"/>
                 <a:cs typeface="Calibri" pitchFamily="34" charset="-120"/>
               </a:rPr>
-              <a:t>T5-base  |  ROUGE-1: 0.4584 ✓</a:t>
+              <a:t>T5-base ✓  |  ROUGE-1: 0.4584 (on par with BART)</a:t>
             </a:r>
             <a:endParaRPr lang="en-US" sz="1100" dirty="0"/>
           </a:p>

</xml_diff>

<commit_message>
Fix factual errors in PPT — all numbers now match real data
- 60.5% abstractive advantage → corrected to 67.9% (=(0.4584-0.2730)/0.2730)
- 68.1% improvement → unified to 67.9% across all slides
- 1,024-token ceiling → corrected to 512-token (verified against actual notebook code)
- 'half the parameters' → '~55% of BART parameters' (220M/400M=55%)
- HuggingFace Spaces now shows both warm (8-15s) and cold start (15-30s) latency
- All numbers now consistent and verified against actual project outputs
</commit_message>
<xml_diff>
--- a/DocSnap_Presentation.pptx
+++ b/DocSnap_Presentation.pptx
@@ -3026,7 +3026,7 @@
                 <a:ea typeface="Trebuchet MS" pitchFamily="34" charset="-122"/>
                 <a:cs typeface="Trebuchet MS" pitchFamily="34" charset="-120"/>
               </a:rPr>
-              <a:t>60.5%</a:t>
+              <a:t>67.9%</a:t>
             </a:r>
             <a:endParaRPr lang="en-US" sz="3600" dirty="0"/>
           </a:p>
@@ -8621,7 +8621,7 @@
                 <a:ea typeface="Trebuchet MS" pitchFamily="34" charset="-122"/>
                 <a:cs typeface="Trebuchet MS" pitchFamily="34" charset="-120"/>
               </a:rPr>
-              <a:t>60.5%</a:t>
+              <a:t>67.9%</a:t>
             </a:r>
             <a:endParaRPr lang="en-US" sz="2200" dirty="0"/>
           </a:p>
@@ -9377,7 +9377,7 @@
                 <a:ea typeface="Trebuchet MS" pitchFamily="34" charset="-122"/>
                 <a:cs typeface="Trebuchet MS" pitchFamily="34" charset="-120"/>
               </a:rPr>
-              <a:t>+68.1%</a:t>
+              <a:t>+67.9%</a:t>
             </a:r>
             <a:endParaRPr lang="en-US" sz="3600" dirty="0"/>
           </a:p>
@@ -9594,7 +9594,7 @@
                 <a:ea typeface="Calibri" pitchFamily="34" charset="-122"/>
                 <a:cs typeface="Calibri" pitchFamily="34" charset="-120"/>
               </a:rPr>
-              <a:t>Conclusion: The 68.1% improvement in ROUGE-1 (T5-base 0.4584 vs TextRank 0.2730) strongly supports H1 on this evaluation set that abstractive summarization substantially outperforms extractive methods on CNN/DailyMail.</a:t>
+              <a:t>Conclusion: The 67.9% improvement in ROUGE-1 (T5-base 0.4584 vs TextRank 0.2730) on the 50-article evaluation set strongly supports H1 — abstractive summarization substantially outperforms extractive methods.</a:t>
             </a:r>
             <a:endParaRPr lang="en-US" sz="1100" dirty="0"/>
           </a:p>
@@ -9884,7 +9884,7 @@
                 <a:ea typeface="Calibri" pitchFamily="34" charset="-122"/>
                 <a:cs typeface="Calibri" pitchFamily="34" charset="-120"/>
               </a:rPr>
-              <a:t>T5-base achieves ROUGE-1 of 0.4584 vs best extractive (TextRank) at 0.2730 — a 60.5% advantage. Confirms abstractive generation produces more human-like summaries.</a:t>
+              <a:t>T5-base achieves ROUGE-1 of 0.4584 vs best extractive (TextRank) at 0.2730 — a 67.9% advantage. Confirms abstractive generation produces more human-like summaries.</a:t>
             </a:r>
             <a:endParaRPr lang="en-US" sz="1100" dirty="0"/>
           </a:p>
@@ -10028,7 +10028,7 @@
                 <a:ea typeface="Calibri" pitchFamily="34" charset="-122"/>
                 <a:cs typeface="Calibri" pitchFamily="34" charset="-120"/>
               </a:rPr>
-              <a:t>T5-base ROUGE-1 = 0.4584 is comparable to the Lewis et al. 2020 BART baseline of 0.4416 — notable given T5-base uses half the parameters (220M vs 400M) and was fine-tuned on only 500 articles vs the full dataset.</a:t>
+              <a:t>T5-base ROUGE-1 = 0.4584 is comparable to the Lewis et al. 2020 BART baseline of 0.4416 — notable given T5-base uses ~55% of BART's parameters (220M vs 400M) and was fine-tuned on only 500 articles vs the full dataset.</a:t>
             </a:r>
             <a:endParaRPr lang="en-US" sz="1100" dirty="0"/>
           </a:p>
@@ -11259,7 +11259,7 @@
                 <a:ea typeface="Calibri" pitchFamily="34" charset="-122"/>
                 <a:cs typeface="Calibri" pitchFamily="34" charset="-120"/>
               </a:rPr>
-              <a:t>• 1.79s average response</a:t>
+              <a:t>• CPU warm: ~8–15s; cold start: ~15–30s</a:t>
             </a:r>
             <a:endParaRPr lang="en-US" sz="1000" dirty="0"/>
           </a:p>
@@ -13015,7 +13015,7 @@
                 <a:ea typeface="Calibri" pitchFamily="34" charset="-122"/>
                 <a:cs typeface="Calibri" pitchFamily="34" charset="-120"/>
               </a:rPr>
-              <a:t>• True performance gap vs extractive is likely larger than 60.5% indicates</a:t>
+              <a:t>• True performance gap vs extractive is likely larger than 67.9% indicates</a:t>
             </a:r>
             <a:endParaRPr lang="en-US" sz="1100" dirty="0"/>
           </a:p>
@@ -13392,7 +13392,7 @@
                 <a:ea typeface="Calibri" pitchFamily="34" charset="-122"/>
                 <a:cs typeface="Calibri" pitchFamily="34" charset="-120"/>
               </a:rPr>
-              <a:t>• 1,024-token ceiling truncates articles &gt;700–750 words during inference</a:t>
+              <a:t>• 512-token input ceiling truncates articles longer than ~380–400 words during inference</a:t>
             </a:r>
             <a:endParaRPr lang="en-US" sz="1100" dirty="0"/>
           </a:p>
@@ -13940,7 +13940,7 @@
                 <a:ea typeface="Calibri" pitchFamily="34" charset="-122"/>
                 <a:cs typeface="Calibri" pitchFamily="34" charset="-120"/>
               </a:rPr>
-              <a:t>T5-base ROUGE-1 of 0.4584 is comparable to the published BART baseline (Lewis et al. 2020: 0.4416) — achieved with half the parameters and 0.17% of the training data, confirming DocSnap's competitiveness.</a:t>
+              <a:t>T5-base ROUGE-1 of 0.4584 is comparable to the published BART baseline (Lewis et al. 2020: 0.4416) — achieved with ~55% of BART's parameters and 0.17% of the training data, confirming DocSnap's competitiveness.</a:t>
             </a:r>
             <a:endParaRPr lang="en-US" sz="1200" dirty="0"/>
           </a:p>
@@ -15932,7 +15932,7 @@
                 <a:ea typeface="Calibri" pitchFamily="34" charset="-122"/>
                 <a:cs typeface="Calibri" pitchFamily="34" charset="-120"/>
               </a:rPr>
-              <a:t>Google Colab free tier limits sessions to ~90 mins. Full 11,490 article evaluation would take 6–7 hours. At n=50, CI is ±0.028 — T5-base leads TextRank by 0.1854 (6× the margin), strongly supporting H1.</a:t>
+              <a:t>Google Colab free tier limits sessions to ~90 mins. Full 11,490 article evaluation would take 6–7 hours. At n=50, CI is ±0.028 — T5-base leads TextRank by 0.1854 (~6.6× the margin), strongly supporting H1.</a:t>
             </a:r>
             <a:endParaRPr lang="en-US" sz="1100" dirty="0"/>
           </a:p>
@@ -20482,7 +20482,7 @@
                 <a:ea typeface="Calibri" pitchFamily="34" charset="-122"/>
                 <a:cs typeface="Calibri" pitchFamily="34" charset="-120"/>
               </a:rPr>
-              <a:t>The two paradigms — and why abstractive wins by 60.5%</a:t>
+              <a:t>The two paradigms — and why abstractive wins by 67.9%</a:t>
             </a:r>
             <a:endParaRPr lang="en-US" sz="1400" dirty="0"/>
           </a:p>

</xml_diff>

<commit_message>
Update PPT — BERT epoch losses corrected to 0.5293 → 0.4563 → 0.2958
</commit_message>
<xml_diff>
--- a/DocSnap_Presentation.pptx
+++ b/DocSnap_Presentation.pptx
@@ -6989,7 +6989,7 @@
                 <a:ea typeface="Calibri" pitchFamily="34" charset="-122"/>
                 <a:cs typeface="Calibri" pitchFamily="34" charset="-120"/>
               </a:rPr>
-              <a:t>0.4821</a:t>
+              <a:t>0.5293</a:t>
             </a:r>
             <a:endParaRPr lang="en-US" sz="1100" dirty="0"/>
           </a:p>
@@ -7053,7 +7053,7 @@
                 <a:ea typeface="Calibri" pitchFamily="34" charset="-122"/>
                 <a:cs typeface="Calibri" pitchFamily="34" charset="-120"/>
               </a:rPr>
-              <a:t>0.3605</a:t>
+              <a:t>0.4563</a:t>
             </a:r>
             <a:endParaRPr lang="en-US" sz="1100" dirty="0"/>
           </a:p>
@@ -7181,7 +7181,7 @@
                 <a:ea typeface="Calibri" pitchFamily="34" charset="-122"/>
                 <a:cs typeface="Calibri" pitchFamily="34" charset="-120"/>
               </a:rPr>
-              <a:t>38.7%</a:t>
+              <a:t>44.1%</a:t>
             </a:r>
             <a:endParaRPr lang="en-US" sz="1100" dirty="0"/>
           </a:p>

</xml_diff>